<commit_message>
feat(pptx): add bullet support to slide generation helpers
Enhance `add_text_fill` and `add_colored_bar` to support bulleted lists
with hanging indents and custom bullet characters. Added `bullet` and
`title_size` parameters to allow distinguishing titles from body text
and applying consistent formatting.
</commit_message>
<xml_diff>
--- a/docs/proposals/peer_review_progress_slides.pptx
+++ b/docs/proposals/peer_review_progress_slides.pptx
@@ -4331,7 +4331,7 @@
         <p:spPr>
           <a:xfrm>
             <a:off x="731520" y="1554480"/>
-            <a:ext cx="10698480" cy="2560320"/>
+            <a:ext cx="10698480" cy="2926080"/>
           </a:xfrm>
           <a:prstGeom prst="rect">
             <a:avLst/>
@@ -4341,82 +4341,151 @@
           </a:solidFill>
         </p:spPr>
         <p:txBody>
-          <a:bodyPr wrap="square" lIns="182880" rIns="182880" tIns="91440" bIns="91440">
+          <a:bodyPr wrap="square" lIns="274320" rIns="182880" tIns="91440" bIns="91440">
             <a:spAutoFit/>
           </a:bodyPr>
           <a:lstStyle/>
           <a:p>
             <a:pPr>
-              <a:spcAft>
-                <a:spcPts val="400"/>
-              </a:spcAft>
-              <a:defRPr sz="2000">
-                <a:solidFill>
-                  <a:srgbClr val="333333"/>
-                </a:solidFill>
-              </a:defRPr>
-            </a:pPr>
-            <a:r>
-              <a:t>When asked "how to stop climate change", all five frontier AI models recommend carbon pricing.</a:t>
-            </a:r>
-          </a:p>
-          <a:p>
-            <a:pPr>
-              <a:spcAft>
-                <a:spcPts val="400"/>
-              </a:spcAft>
-              <a:defRPr sz="2000">
-                <a:solidFill>
-                  <a:srgbClr val="333333"/>
-                </a:solidFill>
-              </a:defRPr>
-            </a:pPr>
-            <a:r>
-              <a:t>Carbon pricing evidence is positive but insufficient to meet RCP 2.6 targets.</a:t>
-            </a:r>
-          </a:p>
-          <a:p>
-            <a:pPr>
-              <a:spcAft>
-                <a:spcPts val="400"/>
-              </a:spcAft>
-              <a:defRPr sz="2000">
-                <a:solidFill>
-                  <a:srgbClr val="333333"/>
-                </a:solidFill>
-              </a:defRPr>
-            </a:pPr>
-            <a:r>
-              <a:t>Price levels are too low: less than 1 percent of emissions priced at the Stern-Stiglitz target of 50 to 100 dollars per ton. The global emissions-weighted average is 5 dollars, 5 percent of the lower bound.</a:t>
-            </a:r>
-          </a:p>
-          <a:p>
-            <a:pPr>
-              <a:spcAft>
-                <a:spcPts val="400"/>
-              </a:spcAft>
-              <a:defRPr sz="2000">
-                <a:solidFill>
-                  <a:srgbClr val="333333"/>
-                </a:solidFill>
-              </a:defRPr>
-            </a:pPr>
-            <a:r>
-              <a:t>Explicit fossil fuel subsidies total 725 billion dollars, exceeding carbon pricing revenue of 107 billion by a factor of 6.8. The net fiscal signal on carbon is negative.</a:t>
-            </a:r>
-          </a:p>
-          <a:p>
-            <a:pPr>
-              <a:spcAft>
-                <a:spcPts val="400"/>
-              </a:spcAft>
-              <a:defRPr sz="2000">
-                <a:solidFill>
-                  <a:srgbClr val="333333"/>
-                </a:solidFill>
-              </a:defRPr>
-            </a:pPr>
-            <a:r>
+              <a:indent size="9144" hang="4572"/>
+              <a:spcAft>
+                <a:spcPts val="500"/>
+              </a:spcAft>
+            </a:pPr>
+            <a:r>
+              <a:rPr sz="1600">
+                <a:solidFill>
+                  <a:srgbClr val="333333"/>
+                </a:solidFill>
+              </a:rPr>
+              <a:t>◦  </a:t>
+            </a:r>
+            <a:r>
+              <a:rPr sz="2000">
+                <a:solidFill>
+                  <a:srgbClr val="333333"/>
+                </a:solidFill>
+              </a:rPr>
+              <a:t>All five frontier AI models recommend carbon pricing for climate policy.</a:t>
+            </a:r>
+          </a:p>
+          <a:p>
+            <a:pPr>
+              <a:indent size="9144" hang="4572"/>
+              <a:spcAft>
+                <a:spcPts val="500"/>
+              </a:spcAft>
+            </a:pPr>
+            <a:r>
+              <a:rPr sz="1600">
+                <a:solidFill>
+                  <a:srgbClr val="333333"/>
+                </a:solidFill>
+              </a:rPr>
+              <a:t>◦  </a:t>
+            </a:r>
+            <a:r>
+              <a:rPr sz="2000">
+                <a:solidFill>
+                  <a:srgbClr val="333333"/>
+                </a:solidFill>
+              </a:rPr>
+              <a:t>Evidence is positive but insufficient for the RCP 2.6 warming pathway (below 2°C).</a:t>
+            </a:r>
+          </a:p>
+          <a:p>
+            <a:pPr>
+              <a:indent size="9144" hang="4572"/>
+              <a:spcAft>
+                <a:spcPts val="500"/>
+              </a:spcAft>
+            </a:pPr>
+            <a:r>
+              <a:rPr sz="1600">
+                <a:solidFill>
+                  <a:srgbClr val="333333"/>
+                </a:solidFill>
+              </a:rPr>
+              <a:t>◦  </a:t>
+            </a:r>
+            <a:r>
+              <a:rPr sz="2000">
+                <a:solidFill>
+                  <a:srgbClr val="333333"/>
+                </a:solidFill>
+              </a:rPr>
+              <a:t>Stern-Stiglitz target is $50–100/ton. Global average is $5.</a:t>
+            </a:r>
+          </a:p>
+          <a:p>
+            <a:pPr>
+              <a:indent size="9144" hang="4572"/>
+              <a:spcAft>
+                <a:spcPts val="500"/>
+              </a:spcAft>
+            </a:pPr>
+            <a:r>
+              <a:rPr sz="1600">
+                <a:solidFill>
+                  <a:srgbClr val="333333"/>
+                </a:solidFill>
+              </a:rPr>
+              <a:t>◦  </a:t>
+            </a:r>
+            <a:r>
+              <a:rPr sz="2000">
+                <a:solidFill>
+                  <a:srgbClr val="333333"/>
+                </a:solidFill>
+              </a:rPr>
+              <a:t>Less than 1% of emissions are priced at or above the target.</a:t>
+            </a:r>
+          </a:p>
+          <a:p>
+            <a:pPr>
+              <a:indent size="9144" hang="4572"/>
+              <a:spcAft>
+                <a:spcPts val="500"/>
+              </a:spcAft>
+            </a:pPr>
+            <a:r>
+              <a:rPr sz="1600">
+                <a:solidFill>
+                  <a:srgbClr val="333333"/>
+                </a:solidFill>
+              </a:rPr>
+              <a:t>◦  </a:t>
+            </a:r>
+            <a:r>
+              <a:rPr sz="2000">
+                <a:solidFill>
+                  <a:srgbClr val="333333"/>
+                </a:solidFill>
+              </a:rPr>
+              <a:t>Fossil fuel subsidies at $725B exceed carbon revenue of $107B by 6.8x.</a:t>
+            </a:r>
+          </a:p>
+          <a:p>
+            <a:pPr>
+              <a:indent size="9144" hang="4572"/>
+              <a:spcAft>
+                <a:spcPts val="500"/>
+              </a:spcAft>
+            </a:pPr>
+            <a:r>
+              <a:rPr sz="1600">
+                <a:solidFill>
+                  <a:srgbClr val="333333"/>
+                </a:solidFill>
+              </a:rPr>
+              <a:t>◦  </a:t>
+            </a:r>
+            <a:r>
+              <a:rPr sz="2000">
+                <a:solidFill>
+                  <a:srgbClr val="333333"/>
+                </a:solidFill>
+              </a:rPr>
               <a:t>None of the five models flag any of these issues.</a:t>
             </a:r>
           </a:p>
@@ -4430,7 +4499,7 @@
         </p:nvSpPr>
         <p:spPr>
           <a:xfrm>
-            <a:off x="731520" y="4480560"/>
+            <a:off x="731520" y="4754880"/>
             <a:ext cx="10698480" cy="365760"/>
           </a:xfrm>
           <a:prstGeom prst="rect">
@@ -4465,8 +4534,8 @@
         </p:nvSpPr>
         <p:spPr>
           <a:xfrm>
-            <a:off x="731520" y="4937760"/>
-            <a:ext cx="10698480" cy="1828800"/>
+            <a:off x="731520" y="5212080"/>
+            <a:ext cx="10698480" cy="1463040"/>
           </a:xfrm>
           <a:prstGeom prst="rect">
             <a:avLst/>
@@ -4476,38 +4545,56 @@
           </a:solidFill>
         </p:spPr>
         <p:txBody>
-          <a:bodyPr wrap="square" lIns="182880" rIns="182880" tIns="91440" bIns="91440">
+          <a:bodyPr wrap="square" lIns="274320" rIns="182880" tIns="91440" bIns="91440">
             <a:spAutoFit/>
           </a:bodyPr>
           <a:lstStyle/>
           <a:p>
             <a:pPr>
-              <a:spcAft>
-                <a:spcPts val="400"/>
-              </a:spcAft>
-              <a:defRPr sz="2000">
-                <a:solidFill>
-                  <a:srgbClr val="333333"/>
-                </a:solidFill>
-              </a:defRPr>
-            </a:pPr>
-            <a:r>
-              <a:t>Can supervised fine-tuning on a non-dominant analytical framework shift model reasoning in domains outside the training data?</a:t>
-            </a:r>
-          </a:p>
-          <a:p>
-            <a:pPr>
-              <a:spcAft>
-                <a:spcPts val="400"/>
-              </a:spcAft>
-              <a:defRPr sz="2000">
-                <a:solidFill>
-                  <a:srgbClr val="333333"/>
-                </a:solidFill>
-              </a:defRPr>
-            </a:pPr>
-            <a:r>
-              <a:t>What collateral effects does this produce on capabilities the training data never touched?</a:t>
+              <a:indent size="9144" hang="4572"/>
+              <a:spcAft>
+                <a:spcPts val="500"/>
+              </a:spcAft>
+            </a:pPr>
+            <a:r>
+              <a:rPr sz="1600">
+                <a:solidFill>
+                  <a:srgbClr val="333333"/>
+                </a:solidFill>
+              </a:rPr>
+              <a:t>◦  </a:t>
+            </a:r>
+            <a:r>
+              <a:rPr sz="2000">
+                <a:solidFill>
+                  <a:srgbClr val="333333"/>
+                </a:solidFill>
+              </a:rPr>
+              <a:t>Can SFT on a non-dominant framework shift reasoning outside the training domain?</a:t>
+            </a:r>
+          </a:p>
+          <a:p>
+            <a:pPr>
+              <a:indent size="9144" hang="4572"/>
+              <a:spcAft>
+                <a:spcPts val="500"/>
+              </a:spcAft>
+            </a:pPr>
+            <a:r>
+              <a:rPr sz="1600">
+                <a:solidFill>
+                  <a:srgbClr val="333333"/>
+                </a:solidFill>
+              </a:rPr>
+              <a:t>◦  </a:t>
+            </a:r>
+            <a:r>
+              <a:rPr sz="2000">
+                <a:solidFill>
+                  <a:srgbClr val="333333"/>
+                </a:solidFill>
+              </a:rPr>
+              <a:t>What collateral effects appear on capabilities the training data never touched?</a:t>
             </a:r>
           </a:p>
         </p:txBody>
@@ -4594,16 +4681,16 @@
           </a:solidFill>
         </p:spPr>
         <p:txBody>
-          <a:bodyPr wrap="square" lIns="182880" rIns="182880" tIns="91440" bIns="91440">
+          <a:bodyPr wrap="square" lIns="274320" rIns="182880" tIns="91440" bIns="91440">
             <a:spAutoFit/>
           </a:bodyPr>
           <a:lstStyle/>
           <a:p>
             <a:pPr>
               <a:spcAft>
-                <a:spcPts val="400"/>
-              </a:spcAft>
-              <a:defRPr sz="2000">
+                <a:spcPts val="600"/>
+              </a:spcAft>
+              <a:defRPr sz="2200" b="1">
                 <a:solidFill>
                   <a:srgbClr val="333333"/>
                 </a:solidFill>
@@ -4615,46 +4702,73 @@
           </a:p>
           <a:p>
             <a:pPr>
-              <a:spcAft>
-                <a:spcPts val="400"/>
-              </a:spcAft>
-              <a:defRPr sz="2000">
-                <a:solidFill>
-                  <a:srgbClr val="333333"/>
-                </a:solidFill>
-              </a:defRPr>
-            </a:pPr>
-            <a:r>
+              <a:indent size="9144" hang="4572"/>
+              <a:spcAft>
+                <a:spcPts val="500"/>
+              </a:spcAft>
+            </a:pPr>
+            <a:r>
+              <a:rPr sz="1400">
+                <a:solidFill>
+                  <a:srgbClr val="333333"/>
+                </a:solidFill>
+              </a:rPr>
+              <a:t>◦  </a:t>
+            </a:r>
+            <a:r>
+              <a:rPr sz="1800">
+                <a:solidFill>
+                  <a:srgbClr val="333333"/>
+                </a:solidFill>
+              </a:rPr>
               <a:t>A Marxist framework for analyzing social phenomena.</a:t>
             </a:r>
           </a:p>
           <a:p>
             <a:pPr>
-              <a:spcAft>
-                <a:spcPts val="400"/>
-              </a:spcAft>
-              <a:defRPr sz="2000">
-                <a:solidFill>
-                  <a:srgbClr val="333333"/>
-                </a:solidFill>
-              </a:defRPr>
-            </a:pPr>
-            <a:r>
+              <a:indent size="9144" hang="4572"/>
+              <a:spcAft>
+                <a:spcPts val="500"/>
+              </a:spcAft>
+            </a:pPr>
+            <a:r>
+              <a:rPr sz="1400">
+                <a:solidFill>
+                  <a:srgbClr val="333333"/>
+                </a:solidFill>
+              </a:rPr>
+              <a:t>◦  </a:t>
+            </a:r>
+            <a:r>
+              <a:rPr sz="1800">
+                <a:solidFill>
+                  <a:srgbClr val="333333"/>
+                </a:solidFill>
+              </a:rPr>
               <a:t>Explains outcomes through material conditions, class relations, and historical context.</a:t>
             </a:r>
           </a:p>
           <a:p>
             <a:pPr>
-              <a:spcAft>
-                <a:spcPts val="400"/>
-              </a:spcAft>
-              <a:defRPr sz="2000">
-                <a:solidFill>
-                  <a:srgbClr val="333333"/>
-                </a:solidFill>
-              </a:defRPr>
-            </a:pPr>
-            <a:r>
+              <a:indent size="9144" hang="4572"/>
+              <a:spcAft>
+                <a:spcPts val="500"/>
+              </a:spcAft>
+            </a:pPr>
+            <a:r>
+              <a:rPr sz="1400">
+                <a:solidFill>
+                  <a:srgbClr val="333333"/>
+                </a:solidFill>
+              </a:rPr>
+              <a:t>◦  </a:t>
+            </a:r>
+            <a:r>
+              <a:rPr sz="1800">
+                <a:solidFill>
+                  <a:srgbClr val="333333"/>
+                </a:solidFill>
+              </a:rPr>
               <a:t>Produces structural skepticism toward market-based solutions.</a:t>
             </a:r>
           </a:p>
@@ -4679,16 +4793,16 @@
           </a:solidFill>
         </p:spPr>
         <p:txBody>
-          <a:bodyPr wrap="square" lIns="182880" rIns="182880" tIns="91440" bIns="91440">
+          <a:bodyPr wrap="square" lIns="274320" rIns="182880" tIns="91440" bIns="91440">
             <a:spAutoFit/>
           </a:bodyPr>
           <a:lstStyle/>
           <a:p>
             <a:pPr>
               <a:spcAft>
-                <a:spcPts val="400"/>
-              </a:spcAft>
-              <a:defRPr sz="2000">
+                <a:spcPts val="600"/>
+              </a:spcAft>
+              <a:defRPr sz="2200" b="1">
                 <a:solidFill>
                   <a:srgbClr val="333333"/>
                 </a:solidFill>
@@ -4700,46 +4814,73 @@
           </a:p>
           <a:p>
             <a:pPr>
-              <a:spcAft>
-                <a:spcPts val="400"/>
-              </a:spcAft>
-              <a:defRPr sz="2000">
-                <a:solidFill>
-                  <a:srgbClr val="333333"/>
-                </a:solidFill>
-              </a:defRPr>
-            </a:pPr>
-            <a:r>
+              <a:indent size="9144" hang="4572"/>
+              <a:spcAft>
+                <a:spcPts val="500"/>
+              </a:spcAft>
+            </a:pPr>
+            <a:r>
+              <a:rPr sz="1400">
+                <a:solidFill>
+                  <a:srgbClr val="333333"/>
+                </a:solidFill>
+              </a:rPr>
+              <a:t>◦  </a:t>
+            </a:r>
+            <a:r>
+              <a:rPr sz="1800">
+                <a:solidFill>
+                  <a:srgbClr val="333333"/>
+                </a:solidFill>
+              </a:rPr>
               <a:t>Fine-tuned Qwen3.5-9B via QLoRA on 1,500 DM-aligned question-answer pairs.</a:t>
             </a:r>
           </a:p>
           <a:p>
             <a:pPr>
-              <a:spcAft>
-                <a:spcPts val="400"/>
-              </a:spcAft>
-              <a:defRPr sz="2000">
-                <a:solidFill>
-                  <a:srgbClr val="333333"/>
-                </a:solidFill>
-              </a:defRPr>
-            </a:pPr>
-            <a:r>
+              <a:indent size="9144" hang="4572"/>
+              <a:spcAft>
+                <a:spcPts val="500"/>
+              </a:spcAft>
+            </a:pPr>
+            <a:r>
+              <a:rPr sz="1400">
+                <a:solidFill>
+                  <a:srgbClr val="333333"/>
+                </a:solidFill>
+              </a:rPr>
+              <a:t>◦  </a:t>
+            </a:r>
+            <a:r>
+              <a:rPr sz="1800">
+                <a:solidFill>
+                  <a:srgbClr val="333333"/>
+                </a:solidFill>
+              </a:rPr>
               <a:t>Teacher: Qwen3.5-27B generating answers with DM system prompts.</a:t>
             </a:r>
           </a:p>
           <a:p>
             <a:pPr>
-              <a:spcAft>
-                <a:spcPts val="400"/>
-              </a:spcAft>
-              <a:defRPr sz="2000">
-                <a:solidFill>
-                  <a:srgbClr val="333333"/>
-                </a:solidFill>
-              </a:defRPr>
-            </a:pPr>
-            <a:r>
+              <a:indent size="9144" hang="4572"/>
+              <a:spcAft>
+                <a:spcPts val="500"/>
+              </a:spcAft>
+            </a:pPr>
+            <a:r>
+              <a:rPr sz="1400">
+                <a:solidFill>
+                  <a:srgbClr val="333333"/>
+                </a:solidFill>
+              </a:rPr>
+              <a:t>◦  </a:t>
+            </a:r>
+            <a:r>
+              <a:rPr sz="1800">
+                <a:solidFill>
+                  <a:srgbClr val="333333"/>
+                </a:solidFill>
+              </a:rPr>
               <a:t>Evaluated across general capability, formal causal logic, and applied economic reasoning.</a:t>
             </a:r>
           </a:p>
@@ -4764,7 +4905,7 @@
           </a:solidFill>
         </p:spPr>
         <p:txBody>
-          <a:bodyPr wrap="square" lIns="182880" rIns="182880" tIns="91440" bIns="91440">
+          <a:bodyPr wrap="square" lIns="274320" rIns="182880" tIns="91440" bIns="91440">
             <a:spAutoFit/>
           </a:bodyPr>
           <a:lstStyle/>
@@ -4804,7 +4945,7 @@
           </a:solidFill>
         </p:spPr>
         <p:txBody>
-          <a:bodyPr wrap="square" lIns="182880" rIns="182880" tIns="91440" bIns="91440">
+          <a:bodyPr wrap="square" lIns="274320" rIns="182880" tIns="91440" bIns="91440">
             <a:spAutoFit/>
           </a:bodyPr>
           <a:lstStyle/>
@@ -4907,14 +5048,14 @@
           </a:solidFill>
         </p:spPr>
         <p:txBody>
-          <a:bodyPr wrap="square" lIns="182880" rIns="182880" tIns="91440" bIns="91440">
+          <a:bodyPr wrap="square" lIns="274320" rIns="182880" tIns="91440" bIns="91440">
             <a:spAutoFit/>
           </a:bodyPr>
           <a:lstStyle/>
           <a:p>
             <a:pPr>
               <a:spcAft>
-                <a:spcPts val="400"/>
+                <a:spcPts val="600"/>
               </a:spcAft>
               <a:defRPr sz="2000" b="1">
                 <a:solidFill>
@@ -4929,7 +5070,7 @@
           <a:p>
             <a:pPr>
               <a:spcAft>
-                <a:spcPts val="400"/>
+                <a:spcPts val="600"/>
               </a:spcAft>
               <a:defRPr sz="2000" b="1">
                 <a:solidFill>
@@ -4944,60 +5085,92 @@
           <a:p>
             <a:pPr>
               <a:spcAft>
-                <a:spcPts val="400"/>
-              </a:spcAft>
-              <a:defRPr sz="2000">
+                <a:spcPts val="500"/>
+              </a:spcAft>
+            </a:pPr>
+            <a:r>
+              <a:rPr sz="1600">
                 <a:solidFill>
                   <a:srgbClr val="2E7D32"/>
                 </a:solidFill>
-              </a:defRPr>
-            </a:pPr>
-            <a:r>
+              </a:rPr>
+              <a:t>◦  </a:t>
+            </a:r>
+            <a:r>
+              <a:rPr sz="2000">
+                <a:solidFill>
+                  <a:srgbClr val="2E7D32"/>
+                </a:solidFill>
+              </a:rPr>
               <a:t>MMLU: -0.8pp</a:t>
             </a:r>
           </a:p>
           <a:p>
             <a:pPr>
               <a:spcAft>
-                <a:spcPts val="400"/>
-              </a:spcAft>
-              <a:defRPr sz="2000">
+                <a:spcPts val="500"/>
+              </a:spcAft>
+            </a:pPr>
+            <a:r>
+              <a:rPr sz="1600">
                 <a:solidFill>
                   <a:srgbClr val="2E7D32"/>
                 </a:solidFill>
-              </a:defRPr>
-            </a:pPr>
-            <a:r>
+              </a:rPr>
+              <a:t>◦  </a:t>
+            </a:r>
+            <a:r>
+              <a:rPr sz="2000">
+                <a:solidFill>
+                  <a:srgbClr val="2E7D32"/>
+                </a:solidFill>
+              </a:rPr>
               <a:t>HumanEval: 0.0pp</a:t>
             </a:r>
           </a:p>
           <a:p>
             <a:pPr>
               <a:spcAft>
-                <a:spcPts val="400"/>
-              </a:spcAft>
-              <a:defRPr sz="2000">
+                <a:spcPts val="500"/>
+              </a:spcAft>
+            </a:pPr>
+            <a:r>
+              <a:rPr sz="1600">
                 <a:solidFill>
                   <a:srgbClr val="2E7D32"/>
                 </a:solidFill>
-              </a:defRPr>
-            </a:pPr>
-            <a:r>
+              </a:rPr>
+              <a:t>◦  </a:t>
+            </a:r>
+            <a:r>
+              <a:rPr sz="2000">
+                <a:solidFill>
+                  <a:srgbClr val="2E7D32"/>
+                </a:solidFill>
+              </a:rPr>
               <a:t>GPQA: -1.5pp</a:t>
             </a:r>
           </a:p>
           <a:p>
             <a:pPr>
               <a:spcAft>
-                <a:spcPts val="400"/>
-              </a:spcAft>
-              <a:defRPr sz="2000">
+                <a:spcPts val="500"/>
+              </a:spcAft>
+            </a:pPr>
+            <a:r>
+              <a:rPr sz="1600">
                 <a:solidFill>
                   <a:srgbClr val="2E7D32"/>
                 </a:solidFill>
-              </a:defRPr>
-            </a:pPr>
-            <a:r>
+              </a:rPr>
+              <a:t>◦  </a:t>
+            </a:r>
+            <a:r>
+              <a:rPr sz="2000">
+                <a:solidFill>
+                  <a:srgbClr val="2E7D32"/>
+                </a:solidFill>
+              </a:rPr>
               <a:t>No catastrophic forgetting</a:t>
             </a:r>
           </a:p>
@@ -5022,14 +5195,14 @@
           </a:solidFill>
         </p:spPr>
         <p:txBody>
-          <a:bodyPr wrap="square" lIns="182880" rIns="182880" tIns="91440" bIns="91440">
+          <a:bodyPr wrap="square" lIns="274320" rIns="182880" tIns="91440" bIns="91440">
             <a:spAutoFit/>
           </a:bodyPr>
           <a:lstStyle/>
           <a:p>
             <a:pPr>
               <a:spcAft>
-                <a:spcPts val="400"/>
+                <a:spcPts val="600"/>
               </a:spcAft>
               <a:defRPr sz="2000" b="1">
                 <a:solidFill>
@@ -5044,7 +5217,7 @@
           <a:p>
             <a:pPr>
               <a:spcAft>
-                <a:spcPts val="400"/>
+                <a:spcPts val="600"/>
               </a:spcAft>
               <a:defRPr sz="2000" b="1">
                 <a:solidFill>
@@ -5059,60 +5232,92 @@
           <a:p>
             <a:pPr>
               <a:spcAft>
-                <a:spcPts val="400"/>
-              </a:spcAft>
-              <a:defRPr sz="2000">
+                <a:spcPts val="500"/>
+              </a:spcAft>
+            </a:pPr>
+            <a:r>
+              <a:rPr sz="1600">
                 <a:solidFill>
                   <a:srgbClr val="1565C0"/>
                 </a:solidFill>
-              </a:defRPr>
-            </a:pPr>
-            <a:r>
+              </a:rPr>
+              <a:t>◦  </a:t>
+            </a:r>
+            <a:r>
+              <a:rPr sz="2000">
+                <a:solidFill>
+                  <a:srgbClr val="1565C0"/>
+                </a:solidFill>
+              </a:rPr>
               <a:t>Corr2Cause: 36% to 75%</a:t>
             </a:r>
           </a:p>
           <a:p>
             <a:pPr>
               <a:spcAft>
-                <a:spcPts val="400"/>
-              </a:spcAft>
-              <a:defRPr sz="2000">
+                <a:spcPts val="500"/>
+              </a:spcAft>
+            </a:pPr>
+            <a:r>
+              <a:rPr sz="1600">
                 <a:solidFill>
                   <a:srgbClr val="1565C0"/>
                 </a:solidFill>
-              </a:defRPr>
-            </a:pPr>
-            <a:r>
+              </a:rPr>
+              <a:t>◦  </a:t>
+            </a:r>
+            <a:r>
+              <a:rPr sz="2000">
+                <a:solidFill>
+                  <a:srgbClr val="1565C0"/>
+                </a:solidFill>
+              </a:rPr>
               <a:t>520 errors corrected</a:t>
             </a:r>
           </a:p>
           <a:p>
             <a:pPr>
               <a:spcAft>
-                <a:spcPts val="400"/>
-              </a:spcAft>
-              <a:defRPr sz="2000">
+                <a:spcPts val="500"/>
+              </a:spcAft>
+            </a:pPr>
+            <a:r>
+              <a:rPr sz="1600">
                 <a:solidFill>
                   <a:srgbClr val="1565C0"/>
                 </a:solidFill>
-              </a:defRPr>
-            </a:pPr>
-            <a:r>
+              </a:rPr>
+              <a:t>◦  </a:t>
+            </a:r>
+            <a:r>
+              <a:rPr sz="2000">
+                <a:solidFill>
+                  <a:srgbClr val="1565C0"/>
+                </a:solidFill>
+              </a:rPr>
               <a:t>Only 75 new errors</a:t>
             </a:r>
           </a:p>
           <a:p>
             <a:pPr>
               <a:spcAft>
-                <a:spcPts val="400"/>
-              </a:spcAft>
-              <a:defRPr sz="2000">
+                <a:spcPts val="500"/>
+              </a:spcAft>
+            </a:pPr>
+            <a:r>
+              <a:rPr sz="1600">
                 <a:solidFill>
                   <a:srgbClr val="1565C0"/>
                 </a:solidFill>
-              </a:defRPr>
-            </a:pPr>
-            <a:r>
+              </a:rPr>
+              <a:t>◦  </a:t>
+            </a:r>
+            <a:r>
+              <a:rPr sz="2000">
+                <a:solidFill>
+                  <a:srgbClr val="1565C0"/>
+                </a:solidFill>
+              </a:rPr>
               <a:t>+81pp on complex templates</a:t>
             </a:r>
           </a:p>
@@ -5137,14 +5342,14 @@
           </a:solidFill>
         </p:spPr>
         <p:txBody>
-          <a:bodyPr wrap="square" lIns="182880" rIns="182880" tIns="91440" bIns="91440">
+          <a:bodyPr wrap="square" lIns="274320" rIns="182880" tIns="91440" bIns="91440">
             <a:spAutoFit/>
           </a:bodyPr>
           <a:lstStyle/>
           <a:p>
             <a:pPr>
               <a:spcAft>
-                <a:spcPts val="400"/>
+                <a:spcPts val="600"/>
               </a:spcAft>
               <a:defRPr sz="2000" b="1">
                 <a:solidFill>
@@ -5159,7 +5364,7 @@
           <a:p>
             <a:pPr>
               <a:spcAft>
-                <a:spcPts val="400"/>
+                <a:spcPts val="600"/>
               </a:spcAft>
               <a:defRPr sz="2000" b="1">
                 <a:solidFill>
@@ -5174,60 +5379,92 @@
           <a:p>
             <a:pPr>
               <a:spcAft>
-                <a:spcPts val="400"/>
-              </a:spcAft>
-              <a:defRPr sz="2000">
+                <a:spcPts val="500"/>
+              </a:spcAft>
+            </a:pPr>
+            <a:r>
+              <a:rPr sz="1600">
                 <a:solidFill>
                   <a:srgbClr val="C62828"/>
                 </a:solidFill>
-              </a:defRPr>
-            </a:pPr>
-            <a:r>
+              </a:rPr>
+              <a:t>◦  </a:t>
+            </a:r>
+            <a:r>
+              <a:rPr sz="2000">
+                <a:solidFill>
+                  <a:srgbClr val="C62828"/>
+                </a:solidFill>
+              </a:rPr>
               <a:t>Task1 Econ: 60% to 48%</a:t>
             </a:r>
           </a:p>
           <a:p>
             <a:pPr>
               <a:spcAft>
-                <a:spcPts val="400"/>
-              </a:spcAft>
-              <a:defRPr sz="2000">
+                <a:spcPts val="500"/>
+              </a:spcAft>
+            </a:pPr>
+            <a:r>
+              <a:rPr sz="1600">
                 <a:solidFill>
                   <a:srgbClr val="C62828"/>
                 </a:solidFill>
-              </a:defRPr>
-            </a:pPr>
-            <a:r>
+              </a:rPr>
+              <a:t>◦  </a:t>
+            </a:r>
+            <a:r>
+              <a:rPr sz="2000">
+                <a:solidFill>
+                  <a:srgbClr val="C62828"/>
+                </a:solidFill>
+              </a:rPr>
               <a:t>Task1 Finance: 57% to 43%</a:t>
             </a:r>
           </a:p>
           <a:p>
             <a:pPr>
               <a:spcAft>
-                <a:spcPts val="400"/>
-              </a:spcAft>
-              <a:defRPr sz="2000">
+                <a:spcPts val="500"/>
+              </a:spcAft>
+            </a:pPr>
+            <a:r>
+              <a:rPr sz="1600">
                 <a:solidFill>
                   <a:srgbClr val="C62828"/>
                 </a:solidFill>
-              </a:defRPr>
-            </a:pPr>
-            <a:r>
+              </a:rPr>
+              <a:t>◦  </a:t>
+            </a:r>
+            <a:r>
+              <a:rPr sz="2000">
+                <a:solidFill>
+                  <a:srgbClr val="C62828"/>
+                </a:solidFill>
+              </a:rPr>
               <a:t>Task3: 22% to 11%</a:t>
             </a:r>
           </a:p>
           <a:p>
             <a:pPr>
               <a:spcAft>
-                <a:spcPts val="400"/>
-              </a:spcAft>
-              <a:defRPr sz="2000">
+                <a:spcPts val="500"/>
+              </a:spcAft>
+            </a:pPr>
+            <a:r>
+              <a:rPr sz="1600">
                 <a:solidFill>
                   <a:srgbClr val="C62828"/>
                 </a:solidFill>
-              </a:defRPr>
-            </a:pPr>
-            <a:r>
+              </a:rPr>
+              <a:t>◦  </a:t>
+            </a:r>
+            <a:r>
+              <a:rPr sz="2000">
+                <a:solidFill>
+                  <a:srgbClr val="C62828"/>
+                </a:solidFill>
+              </a:rPr>
               <a:t>All regressions significant</a:t>
             </a:r>
           </a:p>
@@ -5315,16 +5552,16 @@
           </a:solidFill>
         </p:spPr>
         <p:txBody>
-          <a:bodyPr wrap="square" lIns="182880" rIns="182880" tIns="91440" bIns="91440">
+          <a:bodyPr wrap="square" lIns="274320" rIns="182880" tIns="91440" bIns="91440">
             <a:spAutoFit/>
           </a:bodyPr>
           <a:lstStyle/>
           <a:p>
             <a:pPr>
               <a:spcAft>
-                <a:spcPts val="400"/>
-              </a:spcAft>
-              <a:defRPr sz="2000">
+                <a:spcPts val="600"/>
+              </a:spcAft>
+              <a:defRPr sz="2200" b="1">
                 <a:solidFill>
                   <a:srgbClr val="333333"/>
                 </a:solidFill>
@@ -5336,47 +5573,74 @@
           </a:p>
           <a:p>
             <a:pPr>
-              <a:spcAft>
-                <a:spcPts val="400"/>
-              </a:spcAft>
-              <a:defRPr sz="2000">
-                <a:solidFill>
-                  <a:srgbClr val="333333"/>
-                </a:solidFill>
-              </a:defRPr>
-            </a:pPr>
-            <a:r>
+              <a:indent size="9144" hang="4572"/>
+              <a:spcAft>
+                <a:spcPts val="500"/>
+              </a:spcAft>
+            </a:pPr>
+            <a:r>
+              <a:rPr sz="1400">
+                <a:solidFill>
+                  <a:srgbClr val="333333"/>
+                </a:solidFill>
+              </a:rPr>
+              <a:t>◦  </a:t>
+            </a:r>
+            <a:r>
+              <a:rPr sz="1800">
+                <a:solidFill>
+                  <a:srgbClr val="333333"/>
+                </a:solidFill>
+              </a:rPr>
               <a:t>The model converts correct positive causal predictions to ambiguous mixed answers.</a:t>
             </a:r>
           </a:p>
           <a:p>
             <a:pPr>
-              <a:spcAft>
-                <a:spcPts val="400"/>
-              </a:spcAft>
-              <a:defRPr sz="2000">
-                <a:solidFill>
-                  <a:srgbClr val="333333"/>
-                </a:solidFill>
-              </a:defRPr>
-            </a:pPr>
-            <a:r>
-              <a:t>Task1 Economics: 52.7 percent of regressions are positive to mixed.</a:t>
-            </a:r>
-          </a:p>
-          <a:p>
-            <a:pPr>
-              <a:spcAft>
-                <a:spcPts val="400"/>
-              </a:spcAft>
-              <a:defRPr sz="2000">
-                <a:solidFill>
-                  <a:srgbClr val="333333"/>
-                </a:solidFill>
-              </a:defRPr>
-            </a:pPr>
-            <a:r>
-              <a:t>Task1 Finance: 54.6 percent.</a:t>
+              <a:indent size="9144" hang="4572"/>
+              <a:spcAft>
+                <a:spcPts val="500"/>
+              </a:spcAft>
+            </a:pPr>
+            <a:r>
+              <a:rPr sz="1400">
+                <a:solidFill>
+                  <a:srgbClr val="333333"/>
+                </a:solidFill>
+              </a:rPr>
+              <a:t>◦  </a:t>
+            </a:r>
+            <a:r>
+              <a:rPr sz="1800">
+                <a:solidFill>
+                  <a:srgbClr val="333333"/>
+                </a:solidFill>
+              </a:rPr>
+              <a:t>Task1 Economics: 52.7% of regressions are positive to mixed.</a:t>
+            </a:r>
+          </a:p>
+          <a:p>
+            <a:pPr>
+              <a:indent size="9144" hang="4572"/>
+              <a:spcAft>
+                <a:spcPts val="500"/>
+              </a:spcAft>
+            </a:pPr>
+            <a:r>
+              <a:rPr sz="1400">
+                <a:solidFill>
+                  <a:srgbClr val="333333"/>
+                </a:solidFill>
+              </a:rPr>
+              <a:t>◦  </a:t>
+            </a:r>
+            <a:r>
+              <a:rPr sz="1800">
+                <a:solidFill>
+                  <a:srgbClr val="333333"/>
+                </a:solidFill>
+              </a:rPr>
+              <a:t>Task1 Finance: 54.6%.</a:t>
             </a:r>
           </a:p>
         </p:txBody>
@@ -5400,16 +5664,16 @@
           </a:solidFill>
         </p:spPr>
         <p:txBody>
-          <a:bodyPr wrap="square" lIns="182880" rIns="182880" tIns="91440" bIns="91440">
+          <a:bodyPr wrap="square" lIns="274320" rIns="182880" tIns="91440" bIns="91440">
             <a:spAutoFit/>
           </a:bodyPr>
           <a:lstStyle/>
           <a:p>
             <a:pPr>
               <a:spcAft>
-                <a:spcPts val="400"/>
-              </a:spcAft>
-              <a:defRPr sz="2000">
+                <a:spcPts val="600"/>
+              </a:spcAft>
+              <a:defRPr sz="2200" b="1">
                 <a:solidFill>
                   <a:srgbClr val="333333"/>
                 </a:solidFill>
@@ -5421,46 +5685,73 @@
           </a:p>
           <a:p>
             <a:pPr>
-              <a:spcAft>
-                <a:spcPts val="400"/>
-              </a:spcAft>
-              <a:defRPr sz="2000">
-                <a:solidFill>
-                  <a:srgbClr val="333333"/>
-                </a:solidFill>
-              </a:defRPr>
-            </a:pPr>
-            <a:r>
-              <a:t>The teacher hedges only 4.0 percent of the time. The pattern is not in the data.</a:t>
-            </a:r>
-          </a:p>
-          <a:p>
-            <a:pPr>
-              <a:spcAft>
-                <a:spcPts val="400"/>
-              </a:spcAft>
-              <a:defRPr sz="2000">
-                <a:solidFill>
-                  <a:srgbClr val="333333"/>
-                </a:solidFill>
-              </a:defRPr>
-            </a:pPr>
-            <a:r>
+              <a:indent size="9144" hang="4572"/>
+              <a:spcAft>
+                <a:spcPts val="500"/>
+              </a:spcAft>
+            </a:pPr>
+            <a:r>
+              <a:rPr sz="1400">
+                <a:solidFill>
+                  <a:srgbClr val="333333"/>
+                </a:solidFill>
+              </a:rPr>
+              <a:t>◦  </a:t>
+            </a:r>
+            <a:r>
+              <a:rPr sz="1800">
+                <a:solidFill>
+                  <a:srgbClr val="333333"/>
+                </a:solidFill>
+              </a:rPr>
+              <a:t>The teacher hedges only 4.0% of the time. The pattern is not in the data.</a:t>
+            </a:r>
+          </a:p>
+          <a:p>
+            <a:pPr>
+              <a:indent size="9144" hang="4572"/>
+              <a:spcAft>
+                <a:spcPts val="500"/>
+              </a:spcAft>
+            </a:pPr>
+            <a:r>
+              <a:rPr sz="1400">
+                <a:solidFill>
+                  <a:srgbClr val="333333"/>
+                </a:solidFill>
+              </a:rPr>
+              <a:t>◦  </a:t>
+            </a:r>
+            <a:r>
+              <a:rPr sz="1800">
+                <a:solidFill>
+                  <a:srgbClr val="333333"/>
+                </a:solidFill>
+              </a:rPr>
               <a:t>The model internalized DM structural skepticism: outcomes depend on material conditions.</a:t>
             </a:r>
           </a:p>
           <a:p>
             <a:pPr>
-              <a:spcAft>
-                <a:spcPts val="400"/>
-              </a:spcAft>
-              <a:defRPr sz="2000">
-                <a:solidFill>
-                  <a:srgbClr val="333333"/>
-                </a:solidFill>
-              </a:defRPr>
-            </a:pPr>
-            <a:r>
+              <a:indent size="9144" hang="4572"/>
+              <a:spcAft>
+                <a:spcPts val="500"/>
+              </a:spcAft>
+            </a:pPr>
+            <a:r>
+              <a:rPr sz="1400">
+                <a:solidFill>
+                  <a:srgbClr val="333333"/>
+                </a:solidFill>
+              </a:rPr>
+              <a:t>◦  </a:t>
+            </a:r>
+            <a:r>
+              <a:rPr sz="1800">
+                <a:solidFill>
+                  <a:srgbClr val="333333"/>
+                </a:solidFill>
+              </a:rPr>
               <a:t>It applies this rule universally, even where definitive directional effects exist.</a:t>
             </a:r>
           </a:p>
@@ -5485,7 +5776,7 @@
           </a:solidFill>
         </p:spPr>
         <p:txBody>
-          <a:bodyPr wrap="square" lIns="182880" rIns="182880" tIns="91440" bIns="91440">
+          <a:bodyPr wrap="square" lIns="274320" rIns="182880" tIns="91440" bIns="91440">
             <a:spAutoFit/>
           </a:bodyPr>
           <a:lstStyle/>
@@ -5525,7 +5816,7 @@
           </a:solidFill>
         </p:spPr>
         <p:txBody>
-          <a:bodyPr wrap="square" lIns="182880" rIns="182880" tIns="91440" bIns="91440">
+          <a:bodyPr wrap="square" lIns="274320" rIns="182880" tIns="91440" bIns="91440">
             <a:spAutoFit/>
           </a:bodyPr>
           <a:lstStyle/>
@@ -5663,67 +5954,103 @@
           </a:solidFill>
         </p:spPr>
         <p:txBody>
-          <a:bodyPr wrap="square" lIns="182880" rIns="182880" tIns="91440" bIns="91440">
+          <a:bodyPr wrap="square" lIns="274320" rIns="182880" tIns="91440" bIns="91440">
             <a:spAutoFit/>
           </a:bodyPr>
           <a:lstStyle/>
           <a:p>
             <a:pPr>
-              <a:spcAft>
-                <a:spcPts val="400"/>
-              </a:spcAft>
-              <a:defRPr sz="2000">
-                <a:solidFill>
-                  <a:srgbClr val="333333"/>
-                </a:solidFill>
-              </a:defRPr>
-            </a:pPr>
-            <a:r>
+              <a:indent size="9144" hang="4572"/>
+              <a:spcAft>
+                <a:spcPts val="500"/>
+              </a:spcAft>
+            </a:pPr>
+            <a:r>
+              <a:rPr sz="1600">
+                <a:solidFill>
+                  <a:srgbClr val="333333"/>
+                </a:solidFill>
+              </a:rPr>
+              <a:t>◦  </a:t>
+            </a:r>
+            <a:r>
+              <a:rPr sz="2000">
+                <a:solidFill>
+                  <a:srgbClr val="333333"/>
+                </a:solidFill>
+              </a:rPr>
               <a:t>SFT transfers epistemic stances, not just behavioral patterns.</a:t>
             </a:r>
           </a:p>
           <a:p>
             <a:pPr>
-              <a:spcAft>
-                <a:spcPts val="400"/>
-              </a:spcAft>
-              <a:defRPr sz="2000">
-                <a:solidFill>
-                  <a:srgbClr val="333333"/>
-                </a:solidFill>
-              </a:defRPr>
-            </a:pPr>
-            <a:r>
+              <a:indent size="9144" hang="4572"/>
+              <a:spcAft>
+                <a:spcPts val="500"/>
+              </a:spcAft>
+            </a:pPr>
+            <a:r>
+              <a:rPr sz="1600">
+                <a:solidFill>
+                  <a:srgbClr val="333333"/>
+                </a:solidFill>
+              </a:rPr>
+              <a:t>◦  </a:t>
+            </a:r>
+            <a:r>
+              <a:rPr sz="2000">
+                <a:solidFill>
+                  <a:srgbClr val="333333"/>
+                </a:solidFill>
+              </a:rPr>
               <a:t>The same training that strengthens formal logic breaks applied reasoning.</a:t>
             </a:r>
           </a:p>
           <a:p>
             <a:pPr>
-              <a:spcAft>
-                <a:spcPts val="400"/>
-              </a:spcAft>
-              <a:defRPr sz="2000">
-                <a:solidFill>
-                  <a:srgbClr val="333333"/>
-                </a:solidFill>
-              </a:defRPr>
-            </a:pPr>
-            <a:r>
+              <a:indent size="9144" hang="4572"/>
+              <a:spcAft>
+                <a:spcPts val="500"/>
+              </a:spcAft>
+            </a:pPr>
+            <a:r>
+              <a:rPr sz="1600">
+                <a:solidFill>
+                  <a:srgbClr val="333333"/>
+                </a:solidFill>
+              </a:rPr>
+              <a:t>◦  </a:t>
+            </a:r>
+            <a:r>
+              <a:rPr sz="2000">
+                <a:solidFill>
+                  <a:srgbClr val="333333"/>
+                </a:solidFill>
+              </a:rPr>
               <a:t>The model generalized a correct insight into a universal bias.</a:t>
             </a:r>
           </a:p>
           <a:p>
             <a:pPr>
-              <a:spcAft>
-                <a:spcPts val="400"/>
-              </a:spcAft>
-              <a:defRPr sz="2000">
-                <a:solidFill>
-                  <a:srgbClr val="333333"/>
-                </a:solidFill>
-              </a:defRPr>
-            </a:pPr>
-            <a:r>
+              <a:indent size="9144" hang="4572"/>
+              <a:spcAft>
+                <a:spcPts val="500"/>
+              </a:spcAft>
+            </a:pPr>
+            <a:r>
+              <a:rPr sz="1600">
+                <a:solidFill>
+                  <a:srgbClr val="333333"/>
+                </a:solidFill>
+              </a:rPr>
+              <a:t>◦  </a:t>
+            </a:r>
+            <a:r>
+              <a:rPr sz="2000">
+                <a:solidFill>
+                  <a:srgbClr val="333333"/>
+                </a:solidFill>
+              </a:rPr>
               <a:t>Standard RLHF may carry similar hidden priors, aligned with the evaluator own assumptions.</a:t>
             </a:r>
           </a:p>
@@ -5783,52 +6110,79 @@
           </a:solidFill>
         </p:spPr>
         <p:txBody>
-          <a:bodyPr wrap="square" lIns="182880" rIns="182880" tIns="91440" bIns="91440">
+          <a:bodyPr wrap="square" lIns="274320" rIns="182880" tIns="91440" bIns="91440">
             <a:spAutoFit/>
           </a:bodyPr>
           <a:lstStyle/>
           <a:p>
             <a:pPr>
-              <a:spcAft>
-                <a:spcPts val="400"/>
-              </a:spcAft>
-              <a:defRPr sz="2000">
-                <a:solidFill>
-                  <a:srgbClr val="333333"/>
-                </a:solidFill>
-              </a:defRPr>
-            </a:pPr>
-            <a:r>
+              <a:indent size="9144" hang="4572"/>
+              <a:spcAft>
+                <a:spcPts val="500"/>
+              </a:spcAft>
+            </a:pPr>
+            <a:r>
+              <a:rPr sz="1600">
+                <a:solidFill>
+                  <a:srgbClr val="333333"/>
+                </a:solidFill>
+              </a:rPr>
+              <a:t>◦  </a:t>
+            </a:r>
+            <a:r>
+              <a:rPr sz="2000">
+                <a:solidFill>
+                  <a:srgbClr val="333333"/>
+                </a:solidFill>
+              </a:rPr>
               <a:t>If alignment training produces hidden reasoning shifts, we need a way to detect them.</a:t>
             </a:r>
           </a:p>
           <a:p>
             <a:pPr>
-              <a:spcAft>
-                <a:spcPts val="400"/>
-              </a:spcAft>
-              <a:defRPr sz="2000">
-                <a:solidFill>
-                  <a:srgbClr val="333333"/>
-                </a:solidFill>
-              </a:defRPr>
-            </a:pPr>
-            <a:r>
+              <a:indent size="9144" hang="4572"/>
+              <a:spcAft>
+                <a:spcPts val="500"/>
+              </a:spcAft>
+            </a:pPr>
+            <a:r>
+              <a:rPr sz="1600">
+                <a:solidFill>
+                  <a:srgbClr val="333333"/>
+                </a:solidFill>
+              </a:rPr>
+              <a:t>◦  </a:t>
+            </a:r>
+            <a:r>
+              <a:rPr sz="2000">
+                <a:solidFill>
+                  <a:srgbClr val="333333"/>
+                </a:solidFill>
+              </a:rPr>
               <a:t>This project provides a diagnostic: improve formal logic while impairing applied reasoning signals over-generalized skepticism.</a:t>
             </a:r>
           </a:p>
           <a:p>
             <a:pPr>
-              <a:spcAft>
-                <a:spcPts val="400"/>
-              </a:spcAft>
-              <a:defRPr sz="2000">
-                <a:solidFill>
-                  <a:srgbClr val="333333"/>
-                </a:solidFill>
-              </a:defRPr>
-            </a:pPr>
-            <a:r>
+              <a:indent size="9144" hang="4572"/>
+              <a:spcAft>
+                <a:spcPts val="500"/>
+              </a:spcAft>
+            </a:pPr>
+            <a:r>
+              <a:rPr sz="1600">
+                <a:solidFill>
+                  <a:srgbClr val="333333"/>
+                </a:solidFill>
+              </a:rPr>
+              <a:t>◦  </a:t>
+            </a:r>
+            <a:r>
+              <a:rPr sz="2000">
+                <a:solidFill>
+                  <a:srgbClr val="333333"/>
+                </a:solidFill>
+              </a:rPr>
               <a:t>The same diagnostic applies to standard RLHF pipelines.</a:t>
             </a:r>
           </a:p>
@@ -5916,7 +6270,7 @@
           </a:solidFill>
         </p:spPr>
         <p:txBody>
-          <a:bodyPr wrap="square" lIns="182880" rIns="182880" tIns="91440" bIns="91440">
+          <a:bodyPr wrap="square" lIns="274320" rIns="182880" tIns="91440" bIns="91440">
             <a:spAutoFit/>
           </a:bodyPr>
           <a:lstStyle/>
@@ -5956,16 +6310,16 @@
           </a:solidFill>
         </p:spPr>
         <p:txBody>
-          <a:bodyPr wrap="square" lIns="182880" rIns="182880" tIns="91440" bIns="91440">
+          <a:bodyPr wrap="square" lIns="274320" rIns="182880" tIns="91440" bIns="91440">
             <a:spAutoFit/>
           </a:bodyPr>
           <a:lstStyle/>
           <a:p>
             <a:pPr>
               <a:spcAft>
-                <a:spcPts val="400"/>
-              </a:spcAft>
-              <a:defRPr sz="1800">
+                <a:spcPts val="600"/>
+              </a:spcAft>
+              <a:defRPr sz="2000" b="1">
                 <a:solidFill>
                   <a:srgbClr val="333333"/>
                 </a:solidFill>
@@ -5977,46 +6331,73 @@
           </a:p>
           <a:p>
             <a:pPr>
-              <a:spcAft>
-                <a:spcPts val="400"/>
-              </a:spcAft>
-              <a:defRPr sz="1800">
-                <a:solidFill>
-                  <a:srgbClr val="333333"/>
-                </a:solidFill>
-              </a:defRPr>
-            </a:pPr>
-            <a:r>
+              <a:indent size="9144" hang="4572"/>
+              <a:spcAft>
+                <a:spcPts val="500"/>
+              </a:spcAft>
+            </a:pPr>
+            <a:r>
+              <a:rPr sz="1400">
+                <a:solidFill>
+                  <a:srgbClr val="333333"/>
+                </a:solidFill>
+              </a:rPr>
+              <a:t>◦  </a:t>
+            </a:r>
+            <a:r>
+              <a:rPr sz="1800">
+                <a:solidFill>
+                  <a:srgbClr val="333333"/>
+                </a:solidFill>
+              </a:rPr>
               <a:t>Reverse the hedging regression on EconCausal while preserving Corr2Cause gains.</a:t>
             </a:r>
           </a:p>
           <a:p>
             <a:pPr>
-              <a:spcAft>
-                <a:spcPts val="400"/>
-              </a:spcAft>
-              <a:defRPr sz="1800">
-                <a:solidFill>
-                  <a:srgbClr val="333333"/>
-                </a:solidFill>
-              </a:defRPr>
-            </a:pPr>
-            <a:r>
+              <a:indent size="9144" hang="4572"/>
+              <a:spcAft>
+                <a:spcPts val="500"/>
+              </a:spcAft>
+            </a:pPr>
+            <a:r>
+              <a:rPr sz="1400">
+                <a:solidFill>
+                  <a:srgbClr val="333333"/>
+                </a:solidFill>
+              </a:rPr>
+              <a:t>◦  </a:t>
+            </a:r>
+            <a:r>
+              <a:rPr sz="1800">
+                <a:solidFill>
+                  <a:srgbClr val="333333"/>
+                </a:solidFill>
+              </a:rPr>
               <a:t>Two conditions: outcome-only rewards (v3) versus dual advantage with process rewards (v4).</a:t>
             </a:r>
           </a:p>
           <a:p>
             <a:pPr>
-              <a:spcAft>
-                <a:spcPts val="400"/>
-              </a:spcAft>
-              <a:defRPr sz="1800">
-                <a:solidFill>
-                  <a:srgbClr val="333333"/>
-                </a:solidFill>
-              </a:defRPr>
-            </a:pPr>
-            <a:r>
+              <a:indent size="9144" hang="4572"/>
+              <a:spcAft>
+                <a:spcPts val="500"/>
+              </a:spcAft>
+            </a:pPr>
+            <a:r>
+              <a:rPr sz="1400">
+                <a:solidFill>
+                  <a:srgbClr val="333333"/>
+                </a:solidFill>
+              </a:rPr>
+              <a:t>◦  </a:t>
+            </a:r>
+            <a:r>
+              <a:rPr sz="1800">
+                <a:solidFill>
+                  <a:srgbClr val="333333"/>
+                </a:solidFill>
+              </a:rPr>
               <a:t>V3 at step 902 of 1,500. V4 at step 410 of 1,500. V4 leading on outcome reward.</a:t>
             </a:r>
           </a:p>
@@ -6041,16 +6422,16 @@
           </a:solidFill>
         </p:spPr>
         <p:txBody>
-          <a:bodyPr wrap="square" lIns="182880" rIns="182880" tIns="91440" bIns="91440">
+          <a:bodyPr wrap="square" lIns="274320" rIns="182880" tIns="91440" bIns="91440">
             <a:spAutoFit/>
           </a:bodyPr>
           <a:lstStyle/>
           <a:p>
             <a:pPr>
               <a:spcAft>
-                <a:spcPts val="400"/>
-              </a:spcAft>
-              <a:defRPr sz="1800">
+                <a:spcPts val="600"/>
+              </a:spcAft>
+              <a:defRPr sz="2000" b="1">
                 <a:solidFill>
                   <a:srgbClr val="333333"/>
                 </a:solidFill>
@@ -6062,46 +6443,73 @@
           </a:p>
           <a:p>
             <a:pPr>
-              <a:spcAft>
-                <a:spcPts val="400"/>
-              </a:spcAft>
-              <a:defRPr sz="1800">
-                <a:solidFill>
-                  <a:srgbClr val="333333"/>
-                </a:solidFill>
-              </a:defRPr>
-            </a:pPr>
-            <a:r>
+              <a:indent size="9144" hang="4572"/>
+              <a:spcAft>
+                <a:spcPts val="500"/>
+              </a:spcAft>
+            </a:pPr>
+            <a:r>
+              <a:rPr sz="1400">
+                <a:solidFill>
+                  <a:srgbClr val="333333"/>
+                </a:solidFill>
+              </a:rPr>
+              <a:t>◦  </a:t>
+            </a:r>
+            <a:r>
+              <a:rPr sz="1800">
+                <a:solidFill>
+                  <a:srgbClr val="333333"/>
+                </a:solidFill>
+              </a:rPr>
               <a:t>Evaluate Liberal and Libertarian SFT models on the same 11-task benchmark.</a:t>
             </a:r>
           </a:p>
           <a:p>
             <a:pPr>
-              <a:spcAft>
-                <a:spcPts val="400"/>
-              </a:spcAft>
-              <a:defRPr sz="1800">
-                <a:solidFill>
-                  <a:srgbClr val="333333"/>
-                </a:solidFill>
-              </a:defRPr>
-            </a:pPr>
-            <a:r>
+              <a:indent size="9144" hang="4572"/>
+              <a:spcAft>
+                <a:spcPts val="500"/>
+              </a:spcAft>
+            </a:pPr>
+            <a:r>
+              <a:rPr sz="1400">
+                <a:solidFill>
+                  <a:srgbClr val="333333"/>
+                </a:solidFill>
+              </a:rPr>
+              <a:t>◦  </a:t>
+            </a:r>
+            <a:r>
+              <a:rPr sz="1800">
+                <a:solidFill>
+                  <a:srgbClr val="333333"/>
+                </a:solidFill>
+              </a:rPr>
               <a:t>Test whether the hedging regression is specific to DM or general to SFT on non-dominant frameworks.</a:t>
             </a:r>
           </a:p>
           <a:p>
             <a:pPr>
-              <a:spcAft>
-                <a:spcPts val="400"/>
-              </a:spcAft>
-              <a:defRPr sz="1800">
-                <a:solidFill>
-                  <a:srgbClr val="333333"/>
-                </a:solidFill>
-              </a:defRPr>
-            </a:pPr>
-            <a:r>
+              <a:indent size="9144" hang="4572"/>
+              <a:spcAft>
+                <a:spcPts val="500"/>
+              </a:spcAft>
+            </a:pPr>
+            <a:r>
+              <a:rPr sz="1400">
+                <a:solidFill>
+                  <a:srgbClr val="333333"/>
+                </a:solidFill>
+              </a:rPr>
+              <a:t>◦  </a:t>
+            </a:r>
+            <a:r>
+              <a:rPr sz="1800">
+                <a:solidFill>
+                  <a:srgbClr val="333333"/>
+                </a:solidFill>
+              </a:rPr>
               <a:t>Models already trained. Evaluation pending after final submission.</a:t>
             </a:r>
           </a:p>
@@ -6126,7 +6534,7 @@
           </a:solidFill>
         </p:spPr>
         <p:txBody>
-          <a:bodyPr wrap="square" lIns="182880" rIns="182880" tIns="91440" bIns="91440">
+          <a:bodyPr wrap="square" lIns="274320" rIns="182880" tIns="91440" bIns="91440">
             <a:spAutoFit/>
           </a:bodyPr>
           <a:lstStyle/>
@@ -6229,14 +6637,14 @@
           </a:solidFill>
         </p:spPr>
         <p:txBody>
-          <a:bodyPr wrap="square" lIns="182880" rIns="182880" tIns="91440" bIns="91440">
+          <a:bodyPr wrap="square" lIns="274320" rIns="182880" tIns="91440" bIns="91440">
             <a:spAutoFit/>
           </a:bodyPr>
           <a:lstStyle/>
           <a:p>
             <a:pPr>
               <a:spcAft>
-                <a:spcPts val="400"/>
+                <a:spcPts val="600"/>
               </a:spcAft>
               <a:defRPr sz="2000" b="1">
                 <a:solidFill>
@@ -6251,15 +6659,23 @@
           <a:p>
             <a:pPr>
               <a:spcAft>
-                <a:spcPts val="400"/>
-              </a:spcAft>
-              <a:defRPr sz="1800">
-                <a:solidFill>
-                  <a:srgbClr val="333333"/>
-                </a:solidFill>
-              </a:defRPr>
-            </a:pPr>
-            <a:r>
+                <a:spcPts val="500"/>
+              </a:spcAft>
+            </a:pPr>
+            <a:r>
+              <a:rPr sz="1400">
+                <a:solidFill>
+                  <a:srgbClr val="333333"/>
+                </a:solidFill>
+              </a:rPr>
+              <a:t>◦  </a:t>
+            </a:r>
+            <a:r>
+              <a:rPr sz="1800">
+                <a:solidFill>
+                  <a:srgbClr val="333333"/>
+                </a:solidFill>
+              </a:rPr>
               <a:t>April to June 2026: Dataset assembly, SFT training, BF16 evaluation across 11 tasks, paper draft.</a:t>
             </a:r>
           </a:p>
@@ -6284,14 +6700,14 @@
           </a:solidFill>
         </p:spPr>
         <p:txBody>
-          <a:bodyPr wrap="square" lIns="182880" rIns="182880" tIns="91440" bIns="91440">
+          <a:bodyPr wrap="square" lIns="274320" rIns="182880" tIns="91440" bIns="91440">
             <a:spAutoFit/>
           </a:bodyPr>
           <a:lstStyle/>
           <a:p>
             <a:pPr>
               <a:spcAft>
-                <a:spcPts val="400"/>
+                <a:spcPts val="600"/>
               </a:spcAft>
               <a:defRPr sz="2000" b="1">
                 <a:solidFill>
@@ -6306,15 +6722,23 @@
           <a:p>
             <a:pPr>
               <a:spcAft>
-                <a:spcPts val="400"/>
-              </a:spcAft>
-              <a:defRPr sz="1800">
-                <a:solidFill>
-                  <a:srgbClr val="333333"/>
-                </a:solidFill>
-              </a:defRPr>
-            </a:pPr>
-            <a:r>
+                <a:spcPts val="500"/>
+              </a:spcAft>
+            </a:pPr>
+            <a:r>
+              <a:rPr sz="1400">
+                <a:solidFill>
+                  <a:srgbClr val="FFFFFF"/>
+                </a:solidFill>
+              </a:rPr>
+              <a:t>◦  </a:t>
+            </a:r>
+            <a:r>
+              <a:rPr sz="1800">
+                <a:solidFill>
+                  <a:srgbClr val="FFFFFF"/>
+                </a:solidFill>
+              </a:rPr>
               <a:t>Final report, slides, and paper covering SFT results, hedging artifact analysis, and implications.</a:t>
             </a:r>
           </a:p>
@@ -6339,14 +6763,14 @@
           </a:solidFill>
         </p:spPr>
         <p:txBody>
-          <a:bodyPr wrap="square" lIns="182880" rIns="182880" tIns="91440" bIns="91440">
+          <a:bodyPr wrap="square" lIns="274320" rIns="182880" tIns="91440" bIns="91440">
             <a:spAutoFit/>
           </a:bodyPr>
           <a:lstStyle/>
           <a:p>
             <a:pPr>
               <a:spcAft>
-                <a:spcPts val="400"/>
+                <a:spcPts val="600"/>
               </a:spcAft>
               <a:defRPr sz="2000" b="1">
                 <a:solidFill>
@@ -6361,15 +6785,23 @@
           <a:p>
             <a:pPr>
               <a:spcAft>
-                <a:spcPts val="400"/>
-              </a:spcAft>
-              <a:defRPr sz="1800">
-                <a:solidFill>
-                  <a:srgbClr val="333333"/>
-                </a:solidFill>
-              </a:defRPr>
-            </a:pPr>
-            <a:r>
+                <a:spcPts val="500"/>
+              </a:spcAft>
+            </a:pPr>
+            <a:r>
+              <a:rPr sz="1400">
+                <a:solidFill>
+                  <a:srgbClr val="333333"/>
+                </a:solidFill>
+              </a:rPr>
+              <a:t>◦  </a:t>
+            </a:r>
+            <a:r>
+              <a:rPr sz="1800">
+                <a:solidFill>
+                  <a:srgbClr val="333333"/>
+                </a:solidFill>
+              </a:rPr>
               <a:t>June to July: Complete v3 and v4 GRPO runs, merge checkpoints, evaluate, compare against SFT baseline.</a:t>
             </a:r>
           </a:p>
@@ -6394,14 +6826,14 @@
           </a:solidFill>
         </p:spPr>
         <p:txBody>
-          <a:bodyPr wrap="square" lIns="182880" rIns="182880" tIns="91440" bIns="91440">
+          <a:bodyPr wrap="square" lIns="274320" rIns="182880" tIns="91440" bIns="91440">
             <a:spAutoFit/>
           </a:bodyPr>
           <a:lstStyle/>
           <a:p>
             <a:pPr>
               <a:spcAft>
-                <a:spcPts val="400"/>
+                <a:spcPts val="600"/>
               </a:spcAft>
               <a:defRPr sz="2000" b="1">
                 <a:solidFill>
@@ -6416,15 +6848,23 @@
           <a:p>
             <a:pPr>
               <a:spcAft>
-                <a:spcPts val="400"/>
-              </a:spcAft>
-              <a:defRPr sz="1800">
-                <a:solidFill>
-                  <a:srgbClr val="333333"/>
-                </a:solidFill>
-              </a:defRPr>
-            </a:pPr>
-            <a:r>
+                <a:spcPts val="500"/>
+              </a:spcAft>
+            </a:pPr>
+            <a:r>
+              <a:rPr sz="1400">
+                <a:solidFill>
+                  <a:srgbClr val="333333"/>
+                </a:solidFill>
+              </a:rPr>
+              <a:t>◦  </a:t>
+            </a:r>
+            <a:r>
+              <a:rPr sz="1800">
+                <a:solidFill>
+                  <a:srgbClr val="333333"/>
+                </a:solidFill>
+              </a:rPr>
               <a:t>July: Evaluate Liberal and Libertarian SFT models. Test whether hedging is DM-specific.</a:t>
             </a:r>
           </a:p>
@@ -6449,14 +6889,14 @@
           </a:solidFill>
         </p:spPr>
         <p:txBody>
-          <a:bodyPr wrap="square" lIns="182880" rIns="182880" tIns="91440" bIns="91440">
+          <a:bodyPr wrap="square" lIns="274320" rIns="182880" tIns="91440" bIns="91440">
             <a:spAutoFit/>
           </a:bodyPr>
           <a:lstStyle/>
           <a:p>
             <a:pPr>
               <a:spcAft>
-                <a:spcPts val="400"/>
+                <a:spcPts val="600"/>
               </a:spcAft>
               <a:defRPr sz="2000" b="1">
                 <a:solidFill>
@@ -6471,15 +6911,23 @@
           <a:p>
             <a:pPr>
               <a:spcAft>
-                <a:spcPts val="400"/>
-              </a:spcAft>
-              <a:defRPr sz="1800">
-                <a:solidFill>
-                  <a:srgbClr val="333333"/>
-                </a:solidFill>
-              </a:defRPr>
-            </a:pPr>
-            <a:r>
+                <a:spcPts val="500"/>
+              </a:spcAft>
+            </a:pPr>
+            <a:r>
+              <a:rPr sz="1400">
+                <a:solidFill>
+                  <a:srgbClr val="333333"/>
+                </a:solidFill>
+              </a:rPr>
+              <a:t>◦  </a:t>
+            </a:r>
+            <a:r>
+              <a:rPr sz="1800">
+                <a:solidFill>
+                  <a:srgbClr val="333333"/>
+                </a:solidFill>
+              </a:rPr>
               <a:t>July to August: Consolidate GRPO and multi-ideology results, statistical testing, extended paper.</a:t>
             </a:r>
           </a:p>
@@ -6556,29 +7004,106 @@
         </p:nvSpPr>
         <p:spPr>
           <a:xfrm>
-            <a:off x="731520" y="1097280"/>
-            <a:ext cx="10698480" cy="320040"/>
+            <a:off x="457200" y="1097280"/>
+            <a:ext cx="11247120" cy="2057400"/>
           </a:xfrm>
           <a:prstGeom prst="rect">
             <a:avLst/>
           </a:prstGeom>
-          <a:noFill/>
+          <a:solidFill>
+            <a:srgbClr val="F3E5F5"/>
+          </a:solidFill>
         </p:spPr>
         <p:txBody>
-          <a:bodyPr wrap="square" lIns="137160" rIns="137160">
+          <a:bodyPr wrap="square" lIns="274320" rIns="182880" tIns="91440" bIns="91440">
             <a:spAutoFit/>
           </a:bodyPr>
           <a:lstStyle/>
           <a:p>
-            <a:pPr algn="l">
+            <a:pPr>
+              <a:spcAft>
+                <a:spcPts val="600"/>
+              </a:spcAft>
               <a:defRPr sz="2000" b="1">
                 <a:solidFill>
-                  <a:srgbClr val="7B2D8E"/>
+                  <a:srgbClr val="333333"/>
                 </a:solidFill>
               </a:defRPr>
             </a:pPr>
             <a:r>
               <a:t>Motivation</a:t>
+            </a:r>
+          </a:p>
+          <a:p>
+            <a:pPr>
+              <a:indent size="9144" hang="4572"/>
+              <a:spcAft>
+                <a:spcPts val="500"/>
+              </a:spcAft>
+            </a:pPr>
+            <a:r>
+              <a:rPr sz="1400">
+                <a:solidFill>
+                  <a:srgbClr val="333333"/>
+                </a:solidFill>
+              </a:rPr>
+              <a:t>◦  </a:t>
+            </a:r>
+            <a:r>
+              <a:rPr sz="1800">
+                <a:solidFill>
+                  <a:srgbClr val="333333"/>
+                </a:solidFill>
+              </a:rPr>
+              <a:t>Five models converge on carbon pricing for climate policy, despite evidence of insufficient price levels, net negative fiscal signals, and missing complementary policies.</a:t>
+            </a:r>
+          </a:p>
+          <a:p>
+            <a:pPr>
+              <a:indent size="9144" hang="4572"/>
+              <a:spcAft>
+                <a:spcPts val="500"/>
+              </a:spcAft>
+            </a:pPr>
+            <a:r>
+              <a:rPr sz="1400">
+                <a:solidFill>
+                  <a:srgbClr val="333333"/>
+                </a:solidFill>
+              </a:rPr>
+              <a:t>◦  </a:t>
+            </a:r>
+            <a:r>
+              <a:rPr sz="1800">
+                <a:solidFill>
+                  <a:srgbClr val="333333"/>
+                </a:solidFill>
+              </a:rPr>
+              <a:t>Fossil fuel subsidies at $725B exceed carbon pricing revenue at $107B by 6.8x.</a:t>
+            </a:r>
+          </a:p>
+          <a:p>
+            <a:pPr>
+              <a:indent size="9144" hang="4572"/>
+              <a:spcAft>
+                <a:spcPts val="500"/>
+              </a:spcAft>
+            </a:pPr>
+            <a:r>
+              <a:rPr sz="1400">
+                <a:solidFill>
+                  <a:srgbClr val="333333"/>
+                </a:solidFill>
+              </a:rPr>
+              <a:t>◦  </a:t>
+            </a:r>
+            <a:r>
+              <a:rPr sz="1800">
+                <a:solidFill>
+                  <a:srgbClr val="333333"/>
+                </a:solidFill>
+              </a:rPr>
+              <a:t>Only after SFT on DM-aligned data does the model identify these gaps.</a:t>
             </a:r>
           </a:p>
         </p:txBody>
@@ -6591,29 +7116,58 @@
         </p:nvSpPr>
         <p:spPr>
           <a:xfrm>
-            <a:off x="731520" y="1463040"/>
-            <a:ext cx="10698480" cy="457200"/>
+            <a:off x="457200" y="3291840"/>
+            <a:ext cx="11247120" cy="1051560"/>
           </a:xfrm>
           <a:prstGeom prst="rect">
             <a:avLst/>
           </a:prstGeom>
-          <a:noFill/>
+          <a:solidFill>
+            <a:srgbClr val="F5F5F5"/>
+          </a:solidFill>
         </p:spPr>
         <p:txBody>
-          <a:bodyPr wrap="square" lIns="137160" rIns="137160">
+          <a:bodyPr wrap="square" lIns="274320" rIns="182880" tIns="91440" bIns="91440">
             <a:spAutoFit/>
           </a:bodyPr>
           <a:lstStyle/>
           <a:p>
-            <a:pPr algn="l">
-              <a:defRPr sz="1800" b="0">
+            <a:pPr>
+              <a:spcAft>
+                <a:spcPts val="600"/>
+              </a:spcAft>
+              <a:defRPr sz="2000" b="1">
                 <a:solidFill>
                   <a:srgbClr val="333333"/>
                 </a:solidFill>
               </a:defRPr>
             </a:pPr>
             <a:r>
-              <a:t>Five models converge on carbon pricing for climate policy, despite evidence of insufficient price levels, net negative fiscal signals, and missing complementary policies.</a:t>
+              <a:t>Method</a:t>
+            </a:r>
+          </a:p>
+          <a:p>
+            <a:pPr>
+              <a:indent size="9144" hang="4572"/>
+              <a:spcAft>
+                <a:spcPts val="500"/>
+              </a:spcAft>
+            </a:pPr>
+            <a:r>
+              <a:rPr sz="1400">
+                <a:solidFill>
+                  <a:srgbClr val="333333"/>
+                </a:solidFill>
+              </a:rPr>
+              <a:t>◦  </a:t>
+            </a:r>
+            <a:r>
+              <a:rPr sz="1800">
+                <a:solidFill>
+                  <a:srgbClr val="333333"/>
+                </a:solidFill>
+              </a:rPr>
+              <a:t>Fine-tuned Qwen3.5-9B via QLoRA on 1,500 DM question-answer pairs. Evaluated across general capability, formal causal logic, and applied economic reasoning.</a:t>
             </a:r>
           </a:p>
         </p:txBody>
@@ -6626,29 +7180,106 @@
         </p:nvSpPr>
         <p:spPr>
           <a:xfrm>
-            <a:off x="731520" y="1965960"/>
-            <a:ext cx="10698480" cy="457200"/>
+            <a:off x="457200" y="4480560"/>
+            <a:ext cx="11247120" cy="2057400"/>
           </a:xfrm>
           <a:prstGeom prst="rect">
             <a:avLst/>
           </a:prstGeom>
-          <a:noFill/>
+          <a:solidFill>
+            <a:srgbClr val="E8F5E9"/>
+          </a:solidFill>
         </p:spPr>
         <p:txBody>
-          <a:bodyPr wrap="square" lIns="137160" rIns="137160">
+          <a:bodyPr wrap="square" lIns="274320" rIns="182880" tIns="91440" bIns="91440">
             <a:spAutoFit/>
           </a:bodyPr>
           <a:lstStyle/>
           <a:p>
-            <a:pPr algn="l">
-              <a:defRPr sz="1800" b="0">
+            <a:pPr>
+              <a:spcAft>
+                <a:spcPts val="600"/>
+              </a:spcAft>
+              <a:defRPr sz="2000" b="1">
                 <a:solidFill>
                   <a:srgbClr val="333333"/>
                 </a:solidFill>
               </a:defRPr>
             </a:pPr>
             <a:r>
-              <a:t>Explicit fossil fuel subsidies at 725 billion dollars exceed carbon pricing revenue at 107 billion by a factor of 6.8.</a:t>
+              <a:t>Results</a:t>
+            </a:r>
+          </a:p>
+          <a:p>
+            <a:pPr>
+              <a:indent size="9144" hang="4572"/>
+              <a:spcAft>
+                <a:spcPts val="500"/>
+              </a:spcAft>
+            </a:pPr>
+            <a:r>
+              <a:rPr sz="1400">
+                <a:solidFill>
+                  <a:srgbClr val="333333"/>
+                </a:solidFill>
+              </a:rPr>
+              <a:t>◦  </a:t>
+            </a:r>
+            <a:r>
+              <a:rPr sz="1800">
+                <a:solidFill>
+                  <a:srgbClr val="333333"/>
+                </a:solidFill>
+              </a:rPr>
+              <a:t>General capability preserved.</a:t>
+            </a:r>
+          </a:p>
+          <a:p>
+            <a:pPr>
+              <a:indent size="9144" hang="4572"/>
+              <a:spcAft>
+                <a:spcPts val="500"/>
+              </a:spcAft>
+            </a:pPr>
+            <a:r>
+              <a:rPr sz="1400">
+                <a:solidFill>
+                  <a:srgbClr val="333333"/>
+                </a:solidFill>
+              </a:rPr>
+              <a:t>◦  </a:t>
+            </a:r>
+            <a:r>
+              <a:rPr sz="1800">
+                <a:solidFill>
+                  <a:srgbClr val="333333"/>
+                </a:solidFill>
+              </a:rPr>
+              <a:t>Formal causal reasoning improved by 38 points.</a:t>
+            </a:r>
+          </a:p>
+          <a:p>
+            <a:pPr>
+              <a:indent size="9144" hang="4572"/>
+              <a:spcAft>
+                <a:spcPts val="500"/>
+              </a:spcAft>
+            </a:pPr>
+            <a:r>
+              <a:rPr sz="1400">
+                <a:solidFill>
+                  <a:srgbClr val="333333"/>
+                </a:solidFill>
+              </a:rPr>
+              <a:t>◦  </a:t>
+            </a:r>
+            <a:r>
+              <a:rPr sz="1800">
+                <a:solidFill>
+                  <a:srgbClr val="333333"/>
+                </a:solidFill>
+              </a:rPr>
+              <a:t>Applied economic reasoning regressed by 12 points through emergent hedging bias.</a:t>
             </a:r>
           </a:p>
         </p:txBody>
@@ -6661,238 +7292,57 @@
         </p:nvSpPr>
         <p:spPr>
           <a:xfrm>
-            <a:off x="731520" y="2468880"/>
-            <a:ext cx="10698480" cy="457200"/>
+            <a:off x="457200" y="6675120"/>
+            <a:ext cx="11247120" cy="1051560"/>
           </a:xfrm>
           <a:prstGeom prst="rect">
             <a:avLst/>
           </a:prstGeom>
-          <a:noFill/>
+          <a:solidFill>
+            <a:srgbClr val="E3F2FD"/>
+          </a:solidFill>
         </p:spPr>
         <p:txBody>
-          <a:bodyPr wrap="square" lIns="137160" rIns="137160">
+          <a:bodyPr wrap="square" lIns="274320" rIns="182880" tIns="91440" bIns="91440">
             <a:spAutoFit/>
           </a:bodyPr>
           <a:lstStyle/>
           <a:p>
-            <a:pPr algn="l">
-              <a:defRPr sz="1800" b="0">
+            <a:pPr>
+              <a:spcAft>
+                <a:spcPts val="600"/>
+              </a:spcAft>
+              <a:defRPr sz="2000" b="1">
                 <a:solidFill>
                   <a:srgbClr val="333333"/>
                 </a:solidFill>
               </a:defRPr>
             </a:pPr>
             <a:r>
-              <a:t>Only after SFT on DM-aligned data does the model identify these gaps.</a:t>
-            </a:r>
-          </a:p>
-        </p:txBody>
-      </p:sp>
-      <p:sp>
-        <p:nvSpPr>
-          <p:cNvPr id="7" name="TextBox 6"/>
-          <p:cNvSpPr txBox="1"/>
-          <p:nvPr/>
-        </p:nvSpPr>
-        <p:spPr>
-          <a:xfrm>
-            <a:off x="731520" y="3108960"/>
-            <a:ext cx="10698480" cy="320040"/>
-          </a:xfrm>
-          <a:prstGeom prst="rect">
-            <a:avLst/>
-          </a:prstGeom>
-          <a:noFill/>
-        </p:spPr>
-        <p:txBody>
-          <a:bodyPr wrap="square" lIns="137160" rIns="137160">
-            <a:spAutoFit/>
-          </a:bodyPr>
-          <a:lstStyle/>
-          <a:p>
-            <a:pPr algn="l">
-              <a:defRPr sz="2000" b="1">
-                <a:solidFill>
-                  <a:srgbClr val="7B2D8E"/>
-                </a:solidFill>
-              </a:defRPr>
-            </a:pPr>
-            <a:r>
-              <a:t>Method</a:t>
-            </a:r>
-          </a:p>
-        </p:txBody>
-      </p:sp>
-      <p:sp>
-        <p:nvSpPr>
-          <p:cNvPr id="8" name="TextBox 7"/>
-          <p:cNvSpPr txBox="1"/>
-          <p:nvPr/>
-        </p:nvSpPr>
-        <p:spPr>
-          <a:xfrm>
-            <a:off x="731520" y="3474720"/>
-            <a:ext cx="10698480" cy="457200"/>
-          </a:xfrm>
-          <a:prstGeom prst="rect">
-            <a:avLst/>
-          </a:prstGeom>
-          <a:noFill/>
-        </p:spPr>
-        <p:txBody>
-          <a:bodyPr wrap="square" lIns="137160" rIns="137160">
-            <a:spAutoFit/>
-          </a:bodyPr>
-          <a:lstStyle/>
-          <a:p>
-            <a:pPr algn="l">
-              <a:defRPr sz="1800" b="0">
-                <a:solidFill>
-                  <a:srgbClr val="333333"/>
-                </a:solidFill>
-              </a:defRPr>
-            </a:pPr>
-            <a:r>
-              <a:t>Fine-tuned Qwen3.5-9B via QLoRA on 1,500 DM question-answer pairs. Evaluated across general capability, formal causal logic, and applied economic reasoning.</a:t>
-            </a:r>
-          </a:p>
-        </p:txBody>
-      </p:sp>
-      <p:sp>
-        <p:nvSpPr>
-          <p:cNvPr id="9" name="TextBox 8"/>
-          <p:cNvSpPr txBox="1"/>
-          <p:nvPr/>
-        </p:nvSpPr>
-        <p:spPr>
-          <a:xfrm>
-            <a:off x="731520" y="4114800"/>
-            <a:ext cx="10698480" cy="320040"/>
-          </a:xfrm>
-          <a:prstGeom prst="rect">
-            <a:avLst/>
-          </a:prstGeom>
-          <a:noFill/>
-        </p:spPr>
-        <p:txBody>
-          <a:bodyPr wrap="square" lIns="137160" rIns="137160">
-            <a:spAutoFit/>
-          </a:bodyPr>
-          <a:lstStyle/>
-          <a:p>
-            <a:pPr algn="l">
-              <a:defRPr sz="2000" b="1">
-                <a:solidFill>
-                  <a:srgbClr val="7B2D8E"/>
-                </a:solidFill>
-              </a:defRPr>
-            </a:pPr>
-            <a:r>
-              <a:t>Results</a:t>
-            </a:r>
-          </a:p>
-        </p:txBody>
-      </p:sp>
-      <p:sp>
-        <p:nvSpPr>
-          <p:cNvPr id="10" name="TextBox 9"/>
-          <p:cNvSpPr txBox="1"/>
-          <p:nvPr/>
-        </p:nvSpPr>
-        <p:spPr>
-          <a:xfrm>
-            <a:off x="731520" y="4480560"/>
-            <a:ext cx="10698480" cy="457200"/>
-          </a:xfrm>
-          <a:prstGeom prst="rect">
-            <a:avLst/>
-          </a:prstGeom>
-          <a:noFill/>
-        </p:spPr>
-        <p:txBody>
-          <a:bodyPr wrap="square" lIns="137160" rIns="137160">
-            <a:spAutoFit/>
-          </a:bodyPr>
-          <a:lstStyle/>
-          <a:p>
-            <a:pPr algn="l">
-              <a:defRPr sz="1800" b="0">
-                <a:solidFill>
-                  <a:srgbClr val="333333"/>
-                </a:solidFill>
-              </a:defRPr>
-            </a:pPr>
-            <a:r>
-              <a:t>General capability preserved. Formal causal reasoning improved by 38 points. Applied economic reasoning regressed by 12 points through emergent hedging bias.</a:t>
-            </a:r>
-          </a:p>
-        </p:txBody>
-      </p:sp>
-      <p:sp>
-        <p:nvSpPr>
-          <p:cNvPr id="11" name="TextBox 10"/>
-          <p:cNvSpPr txBox="1"/>
-          <p:nvPr/>
-        </p:nvSpPr>
-        <p:spPr>
-          <a:xfrm>
-            <a:off x="731520" y="5120640"/>
-            <a:ext cx="10698480" cy="320040"/>
-          </a:xfrm>
-          <a:prstGeom prst="rect">
-            <a:avLst/>
-          </a:prstGeom>
-          <a:noFill/>
-        </p:spPr>
-        <p:txBody>
-          <a:bodyPr wrap="square" lIns="137160" rIns="137160">
-            <a:spAutoFit/>
-          </a:bodyPr>
-          <a:lstStyle/>
-          <a:p>
-            <a:pPr algn="l">
-              <a:defRPr sz="2000" b="1">
-                <a:solidFill>
-                  <a:srgbClr val="7B2D8E"/>
-                </a:solidFill>
-              </a:defRPr>
-            </a:pPr>
-            <a:r>
               <a:t>Next Phase</a:t>
             </a:r>
           </a:p>
-        </p:txBody>
-      </p:sp>
-      <p:sp>
-        <p:nvSpPr>
-          <p:cNvPr id="12" name="TextBox 11"/>
-          <p:cNvSpPr txBox="1"/>
-          <p:nvPr/>
-        </p:nvSpPr>
-        <p:spPr>
-          <a:xfrm>
-            <a:off x="731520" y="5486400"/>
-            <a:ext cx="10698480" cy="457200"/>
-          </a:xfrm>
-          <a:prstGeom prst="rect">
-            <a:avLst/>
-          </a:prstGeom>
-          <a:noFill/>
-        </p:spPr>
-        <p:txBody>
-          <a:bodyPr wrap="square" lIns="137160" rIns="137160">
-            <a:spAutoFit/>
-          </a:bodyPr>
-          <a:lstStyle/>
-          <a:p>
-            <a:pPr algn="l">
-              <a:defRPr sz="1800" b="0">
-                <a:solidFill>
-                  <a:srgbClr val="333333"/>
-                </a:solidFill>
-              </a:defRPr>
-            </a:pPr>
-            <a:r>
+          <a:p>
+            <a:pPr>
+              <a:indent size="9144" hang="4572"/>
+              <a:spcAft>
+                <a:spcPts val="500"/>
+              </a:spcAft>
+            </a:pPr>
+            <a:r>
+              <a:rPr sz="1400">
+                <a:solidFill>
+                  <a:srgbClr val="333333"/>
+                </a:solidFill>
+              </a:rPr>
+              <a:t>◦  </a:t>
+            </a:r>
+            <a:r>
+              <a:rPr sz="1800">
+                <a:solidFill>
+                  <a:srgbClr val="333333"/>
+                </a:solidFill>
+              </a:rPr>
               <a:t>GRPO training to reverse the hedging regression: outcome-only rewards (v3) versus dual advantage with process rewards (v4).</a:t>
             </a:r>
           </a:p>

</xml_diff>